<commit_message>
P10: Mise à jour livrables et documentation
</commit_message>
<xml_diff>
--- a/P10_Mettez_en_place_le_pipeline_d_orchestration_des_flux_aymeric_bailleul/_projet/_livrables/ABAI_P10_03_presentation_20250116.pptx
+++ b/P10_Mettez_en_place_le_pipeline_d_orchestration_des_flux_aymeric_bailleul/_projet/_livrables/ABAI_P10_03_presentation_20250116.pptx
@@ -238,7 +238,7 @@
           <a:p>
             <a:fld id="{75D104EB-64CC-414E-BB25-648E13EC7A03}" type="datetimeFigureOut">
               <a:rPr lang="fr-FR" smtClean="0"/>
-              <a:t>27/01/2026</a:t>
+              <a:t>28/01/2026</a:t>
             </a:fld>
             <a:endParaRPr lang="fr-FR"/>
           </a:p>
@@ -416,7 +416,7 @@
           <a:p>
             <a:fld id="{415BB235-7BC9-423D-81A4-4F1BB8787BD1}" type="datetimeFigureOut">
               <a:rPr lang="fr-FR" smtClean="0"/>
-              <a:t>27/01/2026</a:t>
+              <a:t>28/01/2026</a:t>
             </a:fld>
             <a:endParaRPr lang="fr-FR"/>
           </a:p>
@@ -924,7 +924,7 @@
                 <a:ea typeface="+mn-ea"/>
                 <a:cs typeface="+mn-cs"/>
               </a:rPr>
-              <a:t> : Graphique à barres qui affiche la fréquence réelle de vos 714 vins selon leur prix, permettant de visualiser concrètement combien de produits se trouvent dans chaque tranche de prix.</a:t>
+              <a:t> : Graphique à barres qui affiche la fréquence réelle des 714 vins selon leur prix, permettant de visualiser concrètement combien de produits se trouvent dans chaque tranche de prix.</a:t>
             </a:r>
           </a:p>
         </p:txBody>
@@ -1341,25 +1341,8 @@
           </a:bodyPr>
           <a:lstStyle/>
           <a:p>
-            <a:pPr marL="0" marR="0" lvl="0" indent="0" algn="l" defTabSz="914400" rtl="0" eaLnBrk="1" fontAlgn="auto" latinLnBrk="0" hangingPunct="1">
-              <a:lnSpc>
-                <a:spcPct val="100000"/>
-              </a:lnSpc>
-              <a:spcBef>
-                <a:spcPts val="0"/>
-              </a:spcBef>
-              <a:spcAft>
-                <a:spcPts val="0"/>
-              </a:spcAft>
-              <a:buClrTx/>
-              <a:buSzTx/>
-              <a:buFontTx/>
-              <a:buNone/>
-              <a:tabLst/>
-              <a:defRPr/>
-            </a:pPr>
-            <a:r>
-              <a:rPr lang="fr-FR" sz="1200" b="0" i="0" kern="1200" dirty="0">
+            <a:r>
+              <a:rPr lang="fr-FR" sz="1200" b="0" kern="1200" dirty="0" err="1">
                 <a:solidFill>
                   <a:schemeClr val="tx1"/>
                 </a:solidFill>
@@ -1368,10 +1351,10 @@
                 <a:ea typeface="+mn-ea"/>
                 <a:cs typeface="+mn-cs"/>
               </a:rPr>
-              <a:t>Le </a:t>
-            </a:r>
-            <a:r>
-              <a:rPr lang="fr-FR" sz="1200" b="1" i="0" kern="1200" dirty="0" err="1">
+              <a:t>Retry</a:t>
+            </a:r>
+            <a:r>
+              <a:rPr lang="fr-FR" sz="1200" b="0" kern="1200" dirty="0">
                 <a:solidFill>
                   <a:schemeClr val="tx1"/>
                 </a:solidFill>
@@ -1380,10 +1363,10 @@
                 <a:ea typeface="+mn-ea"/>
                 <a:cs typeface="+mn-cs"/>
               </a:rPr>
-              <a:t>backoff</a:t>
-            </a:r>
-            <a:r>
-              <a:rPr lang="fr-FR" sz="1200" b="1" i="0" kern="1200" dirty="0">
+              <a:t> </a:t>
+            </a:r>
+            <a:r>
+              <a:rPr lang="fr-FR" sz="1200" b="0" kern="1200" dirty="0" err="1">
                 <a:solidFill>
                   <a:schemeClr val="tx1"/>
                 </a:solidFill>
@@ -1392,10 +1375,10 @@
                 <a:ea typeface="+mn-ea"/>
                 <a:cs typeface="+mn-cs"/>
               </a:rPr>
-              <a:t> exponentiel</a:t>
-            </a:r>
-            <a:r>
-              <a:rPr lang="fr-FR" sz="1200" b="0" i="0" kern="1200" dirty="0">
+              <a:t>exponential</a:t>
+            </a:r>
+            <a:r>
+              <a:rPr lang="fr-FR" sz="1200" b="0" kern="1200" dirty="0">
                 <a:solidFill>
                   <a:schemeClr val="tx1"/>
                 </a:solidFill>
@@ -1404,17 +1387,56 @@
                 <a:ea typeface="+mn-ea"/>
                 <a:cs typeface="+mn-cs"/>
               </a:rPr>
-              <a:t> augmente progressivement le délai entre les tentatives : 30s → 60s → 120s (au lieu de 30s fixes), ce qui évite de surcharger un service temporairement indisponible.</a:t>
-            </a:r>
-            <a:endParaRPr lang="fr-FR" sz="1200" b="0" kern="1200" dirty="0">
-              <a:solidFill>
-                <a:schemeClr val="tx1"/>
-              </a:solidFill>
-              <a:effectLst/>
-              <a:latin typeface="+mn-lt"/>
-              <a:ea typeface="+mn-ea"/>
-              <a:cs typeface="+mn-cs"/>
-            </a:endParaRPr>
+              <a:t> (10s→20s→40s max 60s, 3 tentatives). Timeout 10min. Validation bloquante (</a:t>
+            </a:r>
+            <a:r>
+              <a:rPr lang="fr-FR" sz="1200" b="0" kern="1200" dirty="0" err="1">
+                <a:solidFill>
+                  <a:schemeClr val="tx1"/>
+                </a:solidFill>
+                <a:effectLst/>
+                <a:latin typeface="+mn-lt"/>
+                <a:ea typeface="+mn-ea"/>
+                <a:cs typeface="+mn-cs"/>
+              </a:rPr>
+              <a:t>allowFailure</a:t>
+            </a:r>
+            <a:r>
+              <a:rPr lang="fr-FR" sz="1200" b="0" kern="1200" dirty="0">
+                <a:solidFill>
+                  <a:schemeClr val="tx1"/>
+                </a:solidFill>
+                <a:effectLst/>
+                <a:latin typeface="+mn-lt"/>
+                <a:ea typeface="+mn-ea"/>
+                <a:cs typeface="+mn-cs"/>
+              </a:rPr>
+              <a:t>=false). Email auto avec détails + lien </a:t>
+            </a:r>
+            <a:r>
+              <a:rPr lang="fr-FR" sz="1200" b="0" kern="1200" dirty="0" err="1">
+                <a:solidFill>
+                  <a:schemeClr val="tx1"/>
+                </a:solidFill>
+                <a:effectLst/>
+                <a:latin typeface="+mn-lt"/>
+                <a:ea typeface="+mn-ea"/>
+                <a:cs typeface="+mn-cs"/>
+              </a:rPr>
+              <a:t>Kestra</a:t>
+            </a:r>
+            <a:r>
+              <a:rPr lang="fr-FR" sz="1200" b="0" kern="1200" dirty="0">
+                <a:solidFill>
+                  <a:schemeClr val="tx1"/>
+                </a:solidFill>
+                <a:effectLst/>
+                <a:latin typeface="+mn-lt"/>
+                <a:ea typeface="+mn-ea"/>
+                <a:cs typeface="+mn-cs"/>
+              </a:rPr>
+              <a:t>.</a:t>
+            </a:r>
           </a:p>
         </p:txBody>
       </p:sp>
@@ -1779,7 +1801,7 @@
                 <a:ea typeface="+mn-ea"/>
                 <a:cs typeface="+mn-cs"/>
               </a:rPr>
-              <a:t>6 tests globaux</a:t>
+              <a:t>5 tests globaux</a:t>
             </a:r>
             <a:r>
               <a:rPr lang="fr-FR" sz="1200" b="0" i="0" kern="1200" dirty="0">
@@ -1989,191 +2011,15 @@
           </a:bodyPr>
           <a:lstStyle/>
           <a:p>
-            <a:r>
-              <a:rPr lang="fr-FR" sz="1200" b="1" i="0" kern="1200" dirty="0">
-                <a:solidFill>
-                  <a:schemeClr val="tx1"/>
-                </a:solidFill>
-                <a:effectLst/>
-                <a:latin typeface="+mn-lt"/>
-                <a:ea typeface="+mn-ea"/>
-                <a:cs typeface="+mn-cs"/>
-              </a:rPr>
-              <a:t>4 tests intermédiaires</a:t>
-            </a:r>
-            <a:r>
-              <a:rPr lang="fr-FR" sz="1200" b="0" i="0" kern="1200" dirty="0">
-                <a:solidFill>
-                  <a:schemeClr val="tx1"/>
-                </a:solidFill>
-                <a:effectLst/>
-                <a:latin typeface="+mn-lt"/>
-                <a:ea typeface="+mn-ea"/>
-                <a:cs typeface="+mn-cs"/>
-              </a:rPr>
-              <a:t> (nettoyage des sources)</a:t>
-            </a:r>
-          </a:p>
-          <a:p>
-            <a:pPr lvl="1"/>
-            <a:r>
-              <a:rPr lang="fr-FR" sz="1200" b="0" i="0" kern="1200" dirty="0">
-                <a:solidFill>
-                  <a:schemeClr val="tx1"/>
-                </a:solidFill>
-                <a:effectLst/>
-                <a:latin typeface="+mn-lt"/>
-                <a:ea typeface="+mn-ea"/>
-                <a:cs typeface="+mn-cs"/>
-              </a:rPr>
-              <a:t>ERP : 825 lignes</a:t>
-            </a:r>
-          </a:p>
-          <a:p>
-            <a:pPr lvl="1"/>
-            <a:r>
-              <a:rPr lang="fr-FR" sz="1200" b="0" i="0" kern="1200" dirty="0">
-                <a:solidFill>
-                  <a:schemeClr val="tx1"/>
-                </a:solidFill>
-                <a:effectLst/>
-                <a:latin typeface="+mn-lt"/>
-                <a:ea typeface="+mn-ea"/>
-                <a:cs typeface="+mn-cs"/>
-              </a:rPr>
-              <a:t>LIAISON : 825 lignes</a:t>
-            </a:r>
-          </a:p>
-          <a:p>
-            <a:pPr lvl="1"/>
-            <a:r>
-              <a:rPr lang="fr-FR" sz="1200" b="0" i="0" kern="1200" dirty="0">
-                <a:solidFill>
-                  <a:schemeClr val="tx1"/>
-                </a:solidFill>
-                <a:effectLst/>
-                <a:latin typeface="+mn-lt"/>
-                <a:ea typeface="+mn-ea"/>
-                <a:cs typeface="+mn-cs"/>
-              </a:rPr>
-              <a:t>WEB étape 1 : 1428 lignes</a:t>
-            </a:r>
-          </a:p>
-          <a:p>
-            <a:pPr lvl="1"/>
-            <a:r>
-              <a:rPr lang="fr-FR" sz="1200" b="0" i="0" kern="1200" dirty="0">
-                <a:solidFill>
-                  <a:schemeClr val="tx1"/>
-                </a:solidFill>
-                <a:effectLst/>
-                <a:latin typeface="+mn-lt"/>
-                <a:ea typeface="+mn-ea"/>
-                <a:cs typeface="+mn-cs"/>
-              </a:rPr>
-              <a:t>WEB étape 2 : 714 lignes</a:t>
-            </a:r>
-          </a:p>
-          <a:p>
-            <a:r>
-              <a:rPr lang="fr-FR" sz="1200" b="1" i="0" kern="1200" dirty="0">
-                <a:solidFill>
-                  <a:schemeClr val="tx1"/>
-                </a:solidFill>
-                <a:effectLst/>
-                <a:latin typeface="+mn-lt"/>
-                <a:ea typeface="+mn-ea"/>
-                <a:cs typeface="+mn-cs"/>
-              </a:rPr>
-              <a:t>6 tests globaux</a:t>
-            </a:r>
-            <a:r>
-              <a:rPr lang="fr-FR" sz="1200" b="0" i="0" kern="1200" dirty="0">
-                <a:solidFill>
-                  <a:schemeClr val="tx1"/>
-                </a:solidFill>
-                <a:effectLst/>
-                <a:latin typeface="+mn-lt"/>
-                <a:ea typeface="+mn-ea"/>
-                <a:cs typeface="+mn-cs"/>
-              </a:rPr>
-              <a:t> (validation finale)</a:t>
-            </a:r>
-          </a:p>
-          <a:p>
-            <a:pPr lvl="1"/>
-            <a:r>
-              <a:rPr lang="fr-FR" sz="1200" b="0" i="0" kern="1200" dirty="0">
-                <a:solidFill>
-                  <a:schemeClr val="tx1"/>
-                </a:solidFill>
-                <a:effectLst/>
-                <a:latin typeface="+mn-lt"/>
-                <a:ea typeface="+mn-ea"/>
-                <a:cs typeface="+mn-cs"/>
-              </a:rPr>
-              <a:t>Cardinalité finale : 714 lignes</a:t>
-            </a:r>
-          </a:p>
-          <a:p>
-            <a:pPr lvl="1"/>
-            <a:r>
-              <a:rPr lang="fr-FR" sz="1200" b="0" i="0" kern="1200" dirty="0">
-                <a:solidFill>
-                  <a:schemeClr val="tx1"/>
-                </a:solidFill>
-                <a:effectLst/>
-                <a:latin typeface="+mn-lt"/>
-                <a:ea typeface="+mn-ea"/>
-                <a:cs typeface="+mn-cs"/>
-              </a:rPr>
-              <a:t>CA total : 70 568,60 €</a:t>
-            </a:r>
-          </a:p>
-          <a:p>
-            <a:pPr lvl="1"/>
-            <a:r>
-              <a:rPr lang="fr-FR" sz="1200" b="0" i="0" kern="1200" dirty="0">
-                <a:solidFill>
-                  <a:schemeClr val="tx1"/>
-                </a:solidFill>
-                <a:effectLst/>
-                <a:latin typeface="+mn-lt"/>
-                <a:ea typeface="+mn-ea"/>
-                <a:cs typeface="+mn-cs"/>
-              </a:rPr>
-              <a:t>Classification premium : 30 vins</a:t>
-            </a:r>
-          </a:p>
-          <a:p>
-            <a:pPr lvl="1"/>
-            <a:r>
-              <a:rPr lang="fr-FR" sz="1200" b="0" i="0" kern="1200" dirty="0">
-                <a:solidFill>
-                  <a:schemeClr val="tx1"/>
-                </a:solidFill>
-                <a:effectLst/>
-                <a:latin typeface="+mn-lt"/>
-                <a:ea typeface="+mn-ea"/>
-                <a:cs typeface="+mn-cs"/>
-              </a:rPr>
-              <a:t>Classification ordinaire : 684 vins</a:t>
-            </a:r>
-          </a:p>
-          <a:p>
-            <a:pPr lvl="1"/>
-            <a:r>
-              <a:rPr lang="fr-FR" sz="1200" b="0" i="0" kern="1200" dirty="0">
-                <a:solidFill>
-                  <a:schemeClr val="tx1"/>
-                </a:solidFill>
-                <a:effectLst/>
-                <a:latin typeface="+mn-lt"/>
-                <a:ea typeface="+mn-ea"/>
-                <a:cs typeface="+mn-cs"/>
-              </a:rPr>
-              <a:t>Intégrité NULL : 0 valeur manquante</a:t>
-            </a:r>
+            <a:endParaRPr lang="fr-FR" sz="1200" b="0" i="0" kern="1200" dirty="0">
+              <a:solidFill>
+                <a:schemeClr val="tx1"/>
+              </a:solidFill>
+              <a:effectLst/>
+              <a:latin typeface="+mn-lt"/>
+              <a:ea typeface="+mn-ea"/>
+              <a:cs typeface="+mn-cs"/>
+            </a:endParaRPr>
           </a:p>
         </p:txBody>
       </p:sp>
@@ -2664,120 +2510,6 @@
           </a:p>
           <a:p>
             <a:r>
-              <a:rPr lang="fr-FR" sz="1200" b="1" i="0" kern="1200" dirty="0" err="1">
-                <a:solidFill>
-                  <a:schemeClr val="tx1"/>
-                </a:solidFill>
-                <a:effectLst/>
-                <a:latin typeface="+mn-lt"/>
-                <a:ea typeface="+mn-ea"/>
-                <a:cs typeface="+mn-cs"/>
-              </a:rPr>
-              <a:t>Airflow</a:t>
-            </a:r>
-            <a:r>
-              <a:rPr lang="fr-FR" sz="1200" b="0" i="0" kern="1200" dirty="0">
-                <a:solidFill>
-                  <a:schemeClr val="tx1"/>
-                </a:solidFill>
-                <a:effectLst/>
-                <a:latin typeface="+mn-lt"/>
-                <a:ea typeface="+mn-ea"/>
-                <a:cs typeface="+mn-cs"/>
-              </a:rPr>
-              <a:t> outil open-source créé par Airbnb (2014) pour </a:t>
-            </a:r>
-            <a:r>
-              <a:rPr lang="fr-FR" sz="1200" b="1" i="0" kern="1200" dirty="0">
-                <a:solidFill>
-                  <a:schemeClr val="tx1"/>
-                </a:solidFill>
-                <a:effectLst/>
-                <a:latin typeface="+mn-lt"/>
-                <a:ea typeface="+mn-ea"/>
-                <a:cs typeface="+mn-cs"/>
-              </a:rPr>
-              <a:t>orchestrer et planifier des workflows de données</a:t>
-            </a:r>
-            <a:r>
-              <a:rPr lang="fr-FR" sz="1200" b="0" i="0" kern="1200" dirty="0">
-                <a:solidFill>
-                  <a:schemeClr val="tx1"/>
-                </a:solidFill>
-                <a:effectLst/>
-                <a:latin typeface="+mn-lt"/>
-                <a:ea typeface="+mn-ea"/>
-                <a:cs typeface="+mn-cs"/>
-              </a:rPr>
-              <a:t> en python</a:t>
-            </a:r>
-          </a:p>
-          <a:p>
-            <a:r>
-              <a:rPr lang="fr-FR" sz="1200" b="1" i="0" kern="1200" dirty="0" err="1">
-                <a:solidFill>
-                  <a:schemeClr val="tx1"/>
-                </a:solidFill>
-                <a:effectLst/>
-                <a:latin typeface="+mn-lt"/>
-                <a:ea typeface="+mn-ea"/>
-                <a:cs typeface="+mn-cs"/>
-              </a:rPr>
-              <a:t>Airflow</a:t>
-            </a:r>
-            <a:r>
-              <a:rPr lang="fr-FR" sz="1200" b="0" i="0" kern="1200" dirty="0">
-                <a:solidFill>
-                  <a:schemeClr val="tx1"/>
-                </a:solidFill>
-                <a:effectLst/>
-                <a:latin typeface="+mn-lt"/>
-                <a:ea typeface="+mn-ea"/>
-                <a:cs typeface="+mn-cs"/>
-              </a:rPr>
-              <a:t> = L'ancien standard du marché</a:t>
-            </a:r>
-            <a:br>
-              <a:rPr lang="fr-FR" dirty="0"/>
-            </a:br>
-            <a:r>
-              <a:rPr lang="fr-FR" sz="1200" b="1" i="0" kern="1200" dirty="0" err="1">
-                <a:solidFill>
-                  <a:schemeClr val="tx1"/>
-                </a:solidFill>
-                <a:effectLst/>
-                <a:latin typeface="+mn-lt"/>
-                <a:ea typeface="+mn-ea"/>
-                <a:cs typeface="+mn-cs"/>
-              </a:rPr>
-              <a:t>Kestra</a:t>
-            </a:r>
-            <a:r>
-              <a:rPr lang="fr-FR" sz="1200" b="0" i="0" kern="1200" dirty="0">
-                <a:solidFill>
-                  <a:schemeClr val="tx1"/>
-                </a:solidFill>
-                <a:effectLst/>
-                <a:latin typeface="+mn-lt"/>
-                <a:ea typeface="+mn-ea"/>
-                <a:cs typeface="+mn-cs"/>
-              </a:rPr>
-              <a:t> = Alternative moderne plus simple</a:t>
-            </a:r>
-          </a:p>
-          <a:p>
-            <a:endParaRPr lang="fr-FR" sz="1200" b="1" i="0" kern="1200" dirty="0">
-              <a:solidFill>
-                <a:schemeClr val="tx1"/>
-              </a:solidFill>
-              <a:effectLst/>
-              <a:latin typeface="+mn-lt"/>
-              <a:ea typeface="+mn-ea"/>
-              <a:cs typeface="+mn-cs"/>
-            </a:endParaRPr>
-          </a:p>
-          <a:p>
-            <a:r>
               <a:rPr lang="fr-FR" sz="1200" b="1" i="0" kern="1200" dirty="0">
                 <a:solidFill>
                   <a:schemeClr val="tx1"/>
@@ -3231,7 +2963,7 @@
                 <a:ea typeface="+mn-ea"/>
                 <a:cs typeface="+mn-cs"/>
               </a:rPr>
-              <a:t>- Validations : 9 points de contrôle</a:t>
+              <a:t>- Validations : 10 points de contrôle</a:t>
             </a:r>
           </a:p>
           <a:p>
@@ -5959,7 +5691,269 @@
                 <a:ea typeface="+mn-ea"/>
                 <a:cs typeface="+mn-cs"/>
               </a:rPr>
-              <a:t>.</a:t>
+              <a:t> </a:t>
+            </a:r>
+            <a:br>
+              <a:rPr lang="fr-FR" sz="1200" b="0" i="0" kern="1200" dirty="0">
+                <a:solidFill>
+                  <a:schemeClr val="tx1"/>
+                </a:solidFill>
+                <a:effectLst/>
+                <a:latin typeface="+mn-lt"/>
+                <a:ea typeface="+mn-ea"/>
+                <a:cs typeface="+mn-cs"/>
+              </a:rPr>
+            </a:br>
+            <a:endParaRPr lang="fr-FR" sz="1200" b="0" i="0" kern="1200" dirty="0">
+              <a:solidFill>
+                <a:schemeClr val="tx1"/>
+              </a:solidFill>
+              <a:effectLst/>
+              <a:latin typeface="+mn-lt"/>
+              <a:ea typeface="+mn-ea"/>
+              <a:cs typeface="+mn-cs"/>
+            </a:endParaRPr>
+          </a:p>
+          <a:p>
+            <a:r>
+              <a:rPr lang="fr-FR" sz="1200" b="1" i="0" kern="1200" dirty="0">
+                <a:solidFill>
+                  <a:schemeClr val="tx1"/>
+                </a:solidFill>
+                <a:effectLst/>
+                <a:latin typeface="+mn-lt"/>
+                <a:ea typeface="+mn-ea"/>
+                <a:cs typeface="+mn-cs"/>
+              </a:rPr>
+              <a:t>Z-score</a:t>
+            </a:r>
+          </a:p>
+          <a:p>
+            <a:r>
+              <a:rPr lang="fr-FR" sz="1200" b="0" i="0" kern="1200" dirty="0">
+                <a:solidFill>
+                  <a:schemeClr val="tx1"/>
+                </a:solidFill>
+                <a:effectLst/>
+                <a:latin typeface="+mn-lt"/>
+                <a:ea typeface="+mn-ea"/>
+                <a:cs typeface="+mn-cs"/>
+              </a:rPr>
+              <a:t>Indique à </a:t>
+            </a:r>
+            <a:r>
+              <a:rPr lang="fr-FR" sz="1200" b="1" i="0" kern="1200" dirty="0">
+                <a:solidFill>
+                  <a:schemeClr val="tx1"/>
+                </a:solidFill>
+                <a:effectLst/>
+                <a:latin typeface="+mn-lt"/>
+                <a:ea typeface="+mn-ea"/>
+                <a:cs typeface="+mn-cs"/>
+              </a:rPr>
+              <a:t>combien d'écarts-types</a:t>
+            </a:r>
+            <a:r>
+              <a:rPr lang="fr-FR" sz="1200" b="0" i="0" kern="1200" dirty="0">
+                <a:solidFill>
+                  <a:schemeClr val="tx1"/>
+                </a:solidFill>
+                <a:effectLst/>
+                <a:latin typeface="+mn-lt"/>
+                <a:ea typeface="+mn-ea"/>
+                <a:cs typeface="+mn-cs"/>
+              </a:rPr>
+              <a:t> une valeur est de la moyenne. Plus z est grand plus la valeur est loin de la moyenne</a:t>
+            </a:r>
+            <a:endParaRPr lang="fr-FR" sz="1200" b="0" kern="1200" dirty="0">
+              <a:solidFill>
+                <a:schemeClr val="tx1"/>
+              </a:solidFill>
+              <a:effectLst/>
+              <a:latin typeface="+mn-lt"/>
+              <a:ea typeface="+mn-ea"/>
+              <a:cs typeface="+mn-cs"/>
+            </a:endParaRPr>
+          </a:p>
+          <a:p>
+            <a:endParaRPr lang="fr-FR" sz="1200" b="0" i="0" kern="1200" dirty="0">
+              <a:solidFill>
+                <a:schemeClr val="tx1"/>
+              </a:solidFill>
+              <a:effectLst/>
+              <a:latin typeface="+mn-lt"/>
+              <a:ea typeface="+mn-ea"/>
+              <a:cs typeface="+mn-cs"/>
+            </a:endParaRPr>
+          </a:p>
+          <a:p>
+            <a:r>
+              <a:rPr lang="fr-FR" sz="1200" b="0" i="0" kern="1200" dirty="0">
+                <a:solidFill>
+                  <a:schemeClr val="tx1"/>
+                </a:solidFill>
+                <a:effectLst/>
+                <a:latin typeface="+mn-lt"/>
+                <a:ea typeface="+mn-ea"/>
+                <a:cs typeface="+mn-cs"/>
+              </a:rPr>
+              <a:t>Dans notre cas un </a:t>
+            </a:r>
+            <a:r>
+              <a:rPr lang="fr-FR" sz="1200" b="1" i="0" kern="1200" dirty="0">
+                <a:solidFill>
+                  <a:schemeClr val="tx1"/>
+                </a:solidFill>
+                <a:effectLst/>
+                <a:latin typeface="+mn-lt"/>
+                <a:ea typeface="+mn-ea"/>
+                <a:cs typeface="+mn-cs"/>
+              </a:rPr>
+              <a:t>Z-score</a:t>
+            </a:r>
+            <a:r>
+              <a:rPr lang="fr-FR" sz="1200" b="0" i="0" kern="1200" dirty="0">
+                <a:solidFill>
+                  <a:schemeClr val="tx1"/>
+                </a:solidFill>
+                <a:effectLst/>
+                <a:latin typeface="+mn-lt"/>
+                <a:ea typeface="+mn-ea"/>
+                <a:cs typeface="+mn-cs"/>
+              </a:rPr>
+              <a:t> a </a:t>
+            </a:r>
+            <a:r>
+              <a:rPr lang="fr-FR" sz="1200" b="1" i="0" kern="1200" dirty="0">
+                <a:solidFill>
+                  <a:schemeClr val="tx1"/>
+                </a:solidFill>
+                <a:effectLst/>
+                <a:latin typeface="+mn-lt"/>
+                <a:ea typeface="+mn-ea"/>
+                <a:cs typeface="+mn-cs"/>
+              </a:rPr>
+              <a:t>2</a:t>
+            </a:r>
+            <a:r>
+              <a:rPr lang="fr-FR" sz="1200" b="0" i="0" kern="1200" dirty="0">
+                <a:solidFill>
+                  <a:schemeClr val="tx1"/>
+                </a:solidFill>
+                <a:effectLst/>
+                <a:latin typeface="+mn-lt"/>
+                <a:ea typeface="+mn-ea"/>
+                <a:cs typeface="+mn-cs"/>
+              </a:rPr>
+              <a:t> signifie </a:t>
+            </a:r>
+            <a:r>
+              <a:rPr lang="fr-FR" sz="1200" b="1" i="0" kern="1200" dirty="0">
+                <a:solidFill>
+                  <a:schemeClr val="tx1"/>
+                </a:solidFill>
+                <a:effectLst/>
+                <a:latin typeface="+mn-lt"/>
+                <a:ea typeface="+mn-ea"/>
+                <a:cs typeface="+mn-cs"/>
+              </a:rPr>
+              <a:t>2 x</a:t>
+            </a:r>
+            <a:r>
+              <a:rPr lang="fr-FR" sz="1200" b="0" i="0" kern="1200" dirty="0">
+                <a:solidFill>
+                  <a:schemeClr val="tx1"/>
+                </a:solidFill>
+                <a:effectLst/>
+                <a:latin typeface="+mn-lt"/>
+                <a:ea typeface="+mn-ea"/>
+                <a:cs typeface="+mn-cs"/>
+              </a:rPr>
+              <a:t> </a:t>
+            </a:r>
+            <a:r>
+              <a:rPr lang="fr-FR" sz="1200" b="1" i="0" kern="1200" dirty="0">
+                <a:solidFill>
+                  <a:schemeClr val="tx1"/>
+                </a:solidFill>
+                <a:effectLst/>
+                <a:latin typeface="+mn-lt"/>
+                <a:ea typeface="+mn-ea"/>
+                <a:cs typeface="+mn-cs"/>
+              </a:rPr>
+              <a:t>Écart-type</a:t>
+            </a:r>
+            <a:r>
+              <a:rPr lang="fr-FR" sz="1200" b="0" i="0" kern="1200" dirty="0">
+                <a:solidFill>
+                  <a:schemeClr val="tx1"/>
+                </a:solidFill>
+                <a:effectLst/>
+                <a:latin typeface="+mn-lt"/>
+                <a:ea typeface="+mn-ea"/>
+                <a:cs typeface="+mn-cs"/>
+              </a:rPr>
+              <a:t> au </a:t>
+            </a:r>
+            <a:r>
+              <a:rPr lang="fr-FR" sz="1200" b="1" i="0" kern="1200" dirty="0">
+                <a:solidFill>
+                  <a:schemeClr val="tx1"/>
+                </a:solidFill>
+                <a:effectLst/>
+                <a:latin typeface="+mn-lt"/>
+                <a:ea typeface="+mn-ea"/>
+                <a:cs typeface="+mn-cs"/>
+              </a:rPr>
+              <a:t>dessus</a:t>
+            </a:r>
+            <a:r>
+              <a:rPr lang="fr-FR" sz="1200" b="0" i="0" kern="1200" dirty="0">
+                <a:solidFill>
+                  <a:schemeClr val="tx1"/>
+                </a:solidFill>
+                <a:effectLst/>
+                <a:latin typeface="+mn-lt"/>
+                <a:ea typeface="+mn-ea"/>
+                <a:cs typeface="+mn-cs"/>
+              </a:rPr>
+              <a:t> de la </a:t>
+            </a:r>
+            <a:r>
+              <a:rPr lang="fr-FR" sz="1200" b="1" i="0" kern="1200" dirty="0">
+                <a:solidFill>
+                  <a:schemeClr val="tx1"/>
+                </a:solidFill>
+                <a:effectLst/>
+                <a:latin typeface="+mn-lt"/>
+                <a:ea typeface="+mn-ea"/>
+                <a:cs typeface="+mn-cs"/>
+              </a:rPr>
+              <a:t>moyenne</a:t>
+            </a:r>
+            <a:r>
+              <a:rPr lang="fr-FR" sz="1200" b="0" i="0" kern="1200" dirty="0">
+                <a:solidFill>
+                  <a:schemeClr val="tx1"/>
+                </a:solidFill>
+                <a:effectLst/>
+                <a:latin typeface="+mn-lt"/>
+                <a:ea typeface="+mn-ea"/>
+                <a:cs typeface="+mn-cs"/>
+              </a:rPr>
+              <a:t> pour être </a:t>
+            </a:r>
+            <a:r>
+              <a:rPr lang="fr-FR" sz="1200" b="1" i="0" kern="1200" dirty="0">
+                <a:solidFill>
+                  <a:schemeClr val="tx1"/>
+                </a:solidFill>
+                <a:effectLst/>
+                <a:latin typeface="+mn-lt"/>
+                <a:ea typeface="+mn-ea"/>
+                <a:cs typeface="+mn-cs"/>
+              </a:rPr>
+              <a:t>un vin premium</a:t>
             </a:r>
           </a:p>
           <a:p>
@@ -5980,67 +5974,6 @@
               <a:tabLst/>
               <a:defRPr/>
             </a:pPr>
-            <a:endParaRPr lang="fr-FR" sz="1200" b="0" kern="1200" dirty="0">
-              <a:solidFill>
-                <a:schemeClr val="tx1"/>
-              </a:solidFill>
-              <a:effectLst/>
-              <a:latin typeface="+mn-lt"/>
-              <a:ea typeface="+mn-ea"/>
-              <a:cs typeface="+mn-cs"/>
-            </a:endParaRPr>
-          </a:p>
-          <a:p>
-            <a:r>
-              <a:rPr lang="fr-FR" sz="1200" b="1" i="0" kern="1200" dirty="0">
-                <a:solidFill>
-                  <a:schemeClr val="tx1"/>
-                </a:solidFill>
-                <a:effectLst/>
-                <a:latin typeface="+mn-lt"/>
-                <a:ea typeface="+mn-ea"/>
-                <a:cs typeface="+mn-cs"/>
-              </a:rPr>
-              <a:t>Z-score</a:t>
-            </a:r>
-          </a:p>
-          <a:p>
-            <a:r>
-              <a:rPr lang="fr-FR" sz="1200" b="0" i="0" kern="1200" dirty="0">
-                <a:solidFill>
-                  <a:schemeClr val="tx1"/>
-                </a:solidFill>
-                <a:effectLst/>
-                <a:latin typeface="+mn-lt"/>
-                <a:ea typeface="+mn-ea"/>
-                <a:cs typeface="+mn-cs"/>
-              </a:rPr>
-              <a:t>Indique à </a:t>
-            </a:r>
-            <a:r>
-              <a:rPr lang="fr-FR" sz="1200" b="1" i="0" kern="1200" dirty="0">
-                <a:solidFill>
-                  <a:schemeClr val="tx1"/>
-                </a:solidFill>
-                <a:effectLst/>
-                <a:latin typeface="+mn-lt"/>
-                <a:ea typeface="+mn-ea"/>
-                <a:cs typeface="+mn-cs"/>
-              </a:rPr>
-              <a:t>combien d'écarts-types</a:t>
-            </a:r>
-            <a:r>
-              <a:rPr lang="fr-FR" sz="1200" b="0" i="0" kern="1200" dirty="0">
-                <a:solidFill>
-                  <a:schemeClr val="tx1"/>
-                </a:solidFill>
-                <a:effectLst/>
-                <a:latin typeface="+mn-lt"/>
-                <a:ea typeface="+mn-ea"/>
-                <a:cs typeface="+mn-cs"/>
-              </a:rPr>
-              <a:t> une valeur est de la moyenne. Plus z est grand plus la valeur est loin de la moyenne</a:t>
-            </a:r>
             <a:endParaRPr lang="fr-FR" sz="1200" b="0" kern="1200" dirty="0">
               <a:solidFill>
                 <a:schemeClr val="tx1"/>
@@ -6275,7 +6208,7 @@
             <a:fld id="{91C81D2E-AC76-4E53-938B-CABEA8435F19}" type="datetimeFigureOut">
               <a:rPr lang="fr-FR" smtClean="0"/>
               <a:pPr/>
-              <a:t>27/01/2026</a:t>
+              <a:t>28/01/2026</a:t>
             </a:fld>
             <a:endParaRPr lang="fr-FR"/>
           </a:p>
@@ -6440,7 +6373,7 @@
             <a:fld id="{91C81D2E-AC76-4E53-938B-CABEA8435F19}" type="datetimeFigureOut">
               <a:rPr lang="fr-FR" smtClean="0"/>
               <a:pPr/>
-              <a:t>27/01/2026</a:t>
+              <a:t>28/01/2026</a:t>
             </a:fld>
             <a:endParaRPr lang="fr-FR"/>
           </a:p>
@@ -6615,7 +6548,7 @@
             <a:fld id="{91C81D2E-AC76-4E53-938B-CABEA8435F19}" type="datetimeFigureOut">
               <a:rPr lang="fr-FR" smtClean="0"/>
               <a:pPr/>
-              <a:t>27/01/2026</a:t>
+              <a:t>28/01/2026</a:t>
             </a:fld>
             <a:endParaRPr lang="fr-FR"/>
           </a:p>
@@ -6780,7 +6713,7 @@
             <a:fld id="{91C81D2E-AC76-4E53-938B-CABEA8435F19}" type="datetimeFigureOut">
               <a:rPr lang="fr-FR" smtClean="0"/>
               <a:pPr/>
-              <a:t>27/01/2026</a:t>
+              <a:t>28/01/2026</a:t>
             </a:fld>
             <a:endParaRPr lang="fr-FR"/>
           </a:p>
@@ -7022,7 +6955,7 @@
             <a:fld id="{91C81D2E-AC76-4E53-938B-CABEA8435F19}" type="datetimeFigureOut">
               <a:rPr lang="fr-FR" smtClean="0"/>
               <a:pPr/>
-              <a:t>27/01/2026</a:t>
+              <a:t>28/01/2026</a:t>
             </a:fld>
             <a:endParaRPr lang="fr-FR"/>
           </a:p>
@@ -7304,7 +7237,7 @@
             <a:fld id="{91C81D2E-AC76-4E53-938B-CABEA8435F19}" type="datetimeFigureOut">
               <a:rPr lang="fr-FR" smtClean="0"/>
               <a:pPr/>
-              <a:t>27/01/2026</a:t>
+              <a:t>28/01/2026</a:t>
             </a:fld>
             <a:endParaRPr lang="fr-FR"/>
           </a:p>
@@ -7720,7 +7653,7 @@
             <a:fld id="{91C81D2E-AC76-4E53-938B-CABEA8435F19}" type="datetimeFigureOut">
               <a:rPr lang="fr-FR" smtClean="0"/>
               <a:pPr/>
-              <a:t>27/01/2026</a:t>
+              <a:t>28/01/2026</a:t>
             </a:fld>
             <a:endParaRPr lang="fr-FR"/>
           </a:p>
@@ -7834,7 +7767,7 @@
             <a:fld id="{91C81D2E-AC76-4E53-938B-CABEA8435F19}" type="datetimeFigureOut">
               <a:rPr lang="fr-FR" smtClean="0"/>
               <a:pPr/>
-              <a:t>27/01/2026</a:t>
+              <a:t>28/01/2026</a:t>
             </a:fld>
             <a:endParaRPr lang="fr-FR"/>
           </a:p>
@@ -7926,7 +7859,7 @@
             <a:fld id="{91C81D2E-AC76-4E53-938B-CABEA8435F19}" type="datetimeFigureOut">
               <a:rPr lang="fr-FR" smtClean="0"/>
               <a:pPr/>
-              <a:t>27/01/2026</a:t>
+              <a:t>28/01/2026</a:t>
             </a:fld>
             <a:endParaRPr lang="fr-FR"/>
           </a:p>
@@ -8198,7 +8131,7 @@
             <a:fld id="{91C81D2E-AC76-4E53-938B-CABEA8435F19}" type="datetimeFigureOut">
               <a:rPr lang="fr-FR" smtClean="0"/>
               <a:pPr/>
-              <a:t>27/01/2026</a:t>
+              <a:t>28/01/2026</a:t>
             </a:fld>
             <a:endParaRPr lang="fr-FR"/>
           </a:p>
@@ -8450,7 +8383,7 @@
             <a:fld id="{91C81D2E-AC76-4E53-938B-CABEA8435F19}" type="datetimeFigureOut">
               <a:rPr lang="fr-FR" smtClean="0"/>
               <a:pPr/>
-              <a:t>27/01/2026</a:t>
+              <a:t>28/01/2026</a:t>
             </a:fld>
             <a:endParaRPr lang="fr-FR"/>
           </a:p>
@@ -8658,7 +8591,7 @@
             <a:fld id="{91C81D2E-AC76-4E53-938B-CABEA8435F19}" type="datetimeFigureOut">
               <a:rPr lang="fr-FR" smtClean="0"/>
               <a:pPr/>
-              <a:t>27/01/2026</a:t>
+              <a:t>28/01/2026</a:t>
             </a:fld>
             <a:endParaRPr lang="fr-FR"/>
           </a:p>
@@ -11124,7 +11057,7 @@
                   </a:schemeClr>
                 </a:solidFill>
               </a:rPr>
-              <a:t>9 	&gt; À l’heure 0</a:t>
+              <a:t>9 	&gt; À l’heure 9</a:t>
             </a:r>
           </a:p>
           <a:p>
@@ -13487,7 +13420,7 @@
                   </a:schemeClr>
                 </a:solidFill>
               </a:rPr>
-              <a:t>10/10 tests automatiques réussis  </a:t>
+              <a:t>9/9 tests automatiques réussis  </a:t>
             </a:r>
           </a:p>
           <a:p>
@@ -14285,7 +14218,7 @@
                   </a:schemeClr>
                 </a:solidFill>
               </a:rPr>
-              <a:t> est une entreprise viticole gérant ces vins via un ERP et une boutique en ligne, 	nécessitant une réconciliation mensuelle de 3 sources de données.</a:t>
+              <a:t> est une entreprise viticole gérant ces vins via un ERP et une boutique en ligne, 	nécessitant une réconciliation mensuelle des 2 sources de données via un fichier de liaison.</a:t>
             </a:r>
           </a:p>
           <a:p>
@@ -16425,55 +16358,6 @@
                 </a:solidFill>
               </a:rPr>
               <a:t>Orchestrateur de workflows open-source</a:t>
-            </a:r>
-          </a:p>
-          <a:p>
-            <a:pPr marL="800100" lvl="3" indent="-342900">
-              <a:buClr>
-                <a:srgbClr val="7030A0"/>
-              </a:buClr>
-              <a:buFont typeface="Wingdings" panose="05000000000000000000" pitchFamily="2" charset="2"/>
-              <a:buChar char="§"/>
-            </a:pPr>
-            <a:r>
-              <a:rPr lang="fr-FR" sz="2400" dirty="0">
-                <a:solidFill>
-                  <a:schemeClr val="bg1">
-                    <a:lumMod val="85000"/>
-                  </a:schemeClr>
-                </a:solidFill>
-              </a:rPr>
-              <a:t>Alternative moderne à </a:t>
-            </a:r>
-            <a:r>
-              <a:rPr lang="fr-FR" sz="2400" dirty="0" err="1">
-                <a:solidFill>
-                  <a:schemeClr val="bg1">
-                    <a:lumMod val="85000"/>
-                  </a:schemeClr>
-                </a:solidFill>
-              </a:rPr>
-              <a:t>Airflow</a:t>
-            </a:r>
-            <a:r>
-              <a:rPr lang="fr-FR" sz="2400" dirty="0">
-                <a:solidFill>
-                  <a:schemeClr val="bg1">
-                    <a:lumMod val="85000"/>
-                  </a:schemeClr>
-                </a:solidFill>
-              </a:rPr>
-              <a:t> </a:t>
-            </a:r>
-            <a:r>
-              <a:rPr lang="fr-FR" sz="1600" i="1" dirty="0">
-                <a:solidFill>
-                  <a:schemeClr val="bg1">
-                    <a:lumMod val="85000"/>
-                  </a:schemeClr>
-                </a:solidFill>
-              </a:rPr>
-              <a:t>(plus simple)</a:t>
             </a:r>
           </a:p>
           <a:p>

</xml_diff>